<commit_message>
Promotion: app logo in the deck, background figures from Munich, Germany and Europe for three personas
Co-Authored-By: Claude Opus 5.5 <noreply@anthropic.com>
</commit_message>
<xml_diff>
--- a/docs/werbung/HiveVoice.pptx
+++ b/docs/werbung/HiveVoice.pptx
@@ -2200,7 +2200,7 @@
         </p:nvSpPr>
         <p:spPr>
           <a:xfrm>
-            <a:off x="457200" y="4754880"/>
+            <a:off x="698500" y="4754880"/>
             <a:ext cx="1828800" cy="274320"/>
           </a:xfrm>
           <a:prstGeom prst="rect">
@@ -2217,12 +2217,12 @@
               <a:buNone/>
             </a:pPr>
             <a:r>
-              <a:rPr lang="en-US" sz="1000" b="1" dirty="0">
-                <a:solidFill>
-                  <a:schemeClr val="tx2"/>
-                </a:solidFill>
-              </a:rPr>
-              <a:t>HiveVoice</a:t>
+              <a:rPr b="1" sz="1000"/>
+              <a:t>hive</a:t>
+            </a:r>
+            <a:r>
+              <a:rPr b="0" sz="1000"/>
+              <a:t>voice</a:t>
             </a:r>
             <a:endParaRPr lang="en-US" sz="1000" dirty="0"/>
           </a:p>
@@ -2270,6 +2270,503 @@
               <a:t>1004</a:t>
             </a:fld>
             <a:endParaRPr lang="en-US"/>
+          </a:p>
+        </p:txBody>
+      </p:sp>
+      <p:sp>
+        <p:nvSpPr>
+          <p:cNvPr id="19" name="logo-0"/>
+          <p:cNvSpPr/>
+          <p:nvPr/>
+        </p:nvSpPr>
+        <p:spPr>
+          <a:xfrm>
+            <a:off x="575749" y="4864354"/>
+            <a:ext cx="43571" cy="50292"/>
+          </a:xfrm>
+          <a:custGeom>
+            <a:avLst/>
+            <a:gdLst/>
+            <a:ahLst/>
+            <a:cxnLst/>
+            <a:rect l="l" t="t" r="r" b="b"/>
+            <a:pathLst>
+              <a:path w="43571" h="50292">
+                <a:moveTo>
+                  <a:pt x="21786" y="0"/>
+                </a:moveTo>
+                <a:lnTo>
+                  <a:pt x="43571" y="12573"/>
+                </a:lnTo>
+                <a:lnTo>
+                  <a:pt x="43571" y="37719"/>
+                </a:lnTo>
+                <a:lnTo>
+                  <a:pt x="21786" y="50292"/>
+                </a:lnTo>
+                <a:lnTo>
+                  <a:pt x="0" y="37719"/>
+                </a:lnTo>
+                <a:lnTo>
+                  <a:pt x="0" y="12573"/>
+                </a:lnTo>
+                <a:close/>
+              </a:path>
+            </a:pathLst>
+          </a:custGeom>
+          <a:solidFill>
+            <a:srgbClr val="111111"/>
+          </a:solidFill>
+          <a:ln>
+            <a:noFill/>
+          </a:ln>
+          <a:effectLst/>
+        </p:spPr>
+        <p:style>
+          <a:lnRef idx="1">
+            <a:schemeClr val="accent1"/>
+          </a:lnRef>
+          <a:fillRef idx="3">
+            <a:schemeClr val="accent1"/>
+          </a:fillRef>
+          <a:effectRef idx="2">
+            <a:schemeClr val="accent1"/>
+          </a:effectRef>
+          <a:fontRef idx="minor">
+            <a:schemeClr val="lt1"/>
+          </a:fontRef>
+        </p:style>
+        <p:txBody>
+          <a:bodyPr rtlCol="0" anchor="ctr"/>
+          <a:lstStyle/>
+          <a:p>
+            <a:pPr algn="ctr"/>
+          </a:p>
+        </p:txBody>
+      </p:sp>
+      <p:sp>
+        <p:nvSpPr>
+          <p:cNvPr id="20" name="logo-1"/>
+          <p:cNvSpPr/>
+          <p:nvPr/>
+        </p:nvSpPr>
+        <p:spPr>
+          <a:xfrm>
+            <a:off x="472879" y="4864354"/>
+            <a:ext cx="43571" cy="50292"/>
+          </a:xfrm>
+          <a:custGeom>
+            <a:avLst/>
+            <a:gdLst/>
+            <a:ahLst/>
+            <a:cxnLst/>
+            <a:rect l="l" t="t" r="r" b="b"/>
+            <a:pathLst>
+              <a:path w="43571" h="50292">
+                <a:moveTo>
+                  <a:pt x="21786" y="0"/>
+                </a:moveTo>
+                <a:lnTo>
+                  <a:pt x="43571" y="12573"/>
+                </a:lnTo>
+                <a:lnTo>
+                  <a:pt x="43571" y="37719"/>
+                </a:lnTo>
+                <a:lnTo>
+                  <a:pt x="21786" y="50292"/>
+                </a:lnTo>
+                <a:lnTo>
+                  <a:pt x="0" y="37719"/>
+                </a:lnTo>
+                <a:lnTo>
+                  <a:pt x="0" y="12573"/>
+                </a:lnTo>
+                <a:close/>
+              </a:path>
+            </a:pathLst>
+          </a:custGeom>
+          <a:solidFill>
+            <a:srgbClr val="111111"/>
+          </a:solidFill>
+          <a:ln>
+            <a:noFill/>
+          </a:ln>
+          <a:effectLst/>
+        </p:spPr>
+        <p:style>
+          <a:lnRef idx="1">
+            <a:schemeClr val="accent1"/>
+          </a:lnRef>
+          <a:fillRef idx="3">
+            <a:schemeClr val="accent1"/>
+          </a:fillRef>
+          <a:effectRef idx="2">
+            <a:schemeClr val="accent1"/>
+          </a:effectRef>
+          <a:fontRef idx="minor">
+            <a:schemeClr val="lt1"/>
+          </a:fontRef>
+        </p:style>
+        <p:txBody>
+          <a:bodyPr rtlCol="0" anchor="ctr"/>
+          <a:lstStyle/>
+          <a:p>
+            <a:pPr algn="ctr"/>
+          </a:p>
+        </p:txBody>
+      </p:sp>
+      <p:sp>
+        <p:nvSpPr>
+          <p:cNvPr id="21" name="logo-2"/>
+          <p:cNvSpPr/>
+          <p:nvPr/>
+        </p:nvSpPr>
+        <p:spPr>
+          <a:xfrm>
+            <a:off x="550031" y="4819777"/>
+            <a:ext cx="43572" cy="50292"/>
+          </a:xfrm>
+          <a:custGeom>
+            <a:avLst/>
+            <a:gdLst/>
+            <a:ahLst/>
+            <a:cxnLst/>
+            <a:rect l="l" t="t" r="r" b="b"/>
+            <a:pathLst>
+              <a:path w="43572" h="50292">
+                <a:moveTo>
+                  <a:pt x="21786" y="0"/>
+                </a:moveTo>
+                <a:lnTo>
+                  <a:pt x="43572" y="12573"/>
+                </a:lnTo>
+                <a:lnTo>
+                  <a:pt x="43572" y="37719"/>
+                </a:lnTo>
+                <a:lnTo>
+                  <a:pt x="21786" y="50292"/>
+                </a:lnTo>
+                <a:lnTo>
+                  <a:pt x="0" y="37719"/>
+                </a:lnTo>
+                <a:lnTo>
+                  <a:pt x="0" y="12573"/>
+                </a:lnTo>
+                <a:close/>
+              </a:path>
+            </a:pathLst>
+          </a:custGeom>
+          <a:solidFill>
+            <a:srgbClr val="111111"/>
+          </a:solidFill>
+          <a:ln>
+            <a:noFill/>
+          </a:ln>
+          <a:effectLst/>
+        </p:spPr>
+        <p:style>
+          <a:lnRef idx="1">
+            <a:schemeClr val="accent1"/>
+          </a:lnRef>
+          <a:fillRef idx="3">
+            <a:schemeClr val="accent1"/>
+          </a:fillRef>
+          <a:effectRef idx="2">
+            <a:schemeClr val="accent1"/>
+          </a:effectRef>
+          <a:fontRef idx="minor">
+            <a:schemeClr val="lt1"/>
+          </a:fontRef>
+        </p:style>
+        <p:txBody>
+          <a:bodyPr rtlCol="0" anchor="ctr"/>
+          <a:lstStyle/>
+          <a:p>
+            <a:pPr algn="ctr"/>
+          </a:p>
+        </p:txBody>
+      </p:sp>
+      <p:sp>
+        <p:nvSpPr>
+          <p:cNvPr id="22" name="logo-3"/>
+          <p:cNvSpPr/>
+          <p:nvPr/>
+        </p:nvSpPr>
+        <p:spPr>
+          <a:xfrm>
+            <a:off x="498596" y="4819777"/>
+            <a:ext cx="43572" cy="50292"/>
+          </a:xfrm>
+          <a:custGeom>
+            <a:avLst/>
+            <a:gdLst/>
+            <a:ahLst/>
+            <a:cxnLst/>
+            <a:rect l="l" t="t" r="r" b="b"/>
+            <a:pathLst>
+              <a:path w="43572" h="50292">
+                <a:moveTo>
+                  <a:pt x="21786" y="0"/>
+                </a:moveTo>
+                <a:lnTo>
+                  <a:pt x="43572" y="12573"/>
+                </a:lnTo>
+                <a:lnTo>
+                  <a:pt x="43572" y="37719"/>
+                </a:lnTo>
+                <a:lnTo>
+                  <a:pt x="21786" y="50292"/>
+                </a:lnTo>
+                <a:lnTo>
+                  <a:pt x="0" y="37719"/>
+                </a:lnTo>
+                <a:lnTo>
+                  <a:pt x="0" y="12573"/>
+                </a:lnTo>
+                <a:close/>
+              </a:path>
+            </a:pathLst>
+          </a:custGeom>
+          <a:solidFill>
+            <a:srgbClr val="111111"/>
+          </a:solidFill>
+          <a:ln>
+            <a:noFill/>
+          </a:ln>
+          <a:effectLst/>
+        </p:spPr>
+        <p:style>
+          <a:lnRef idx="1">
+            <a:schemeClr val="accent1"/>
+          </a:lnRef>
+          <a:fillRef idx="3">
+            <a:schemeClr val="accent1"/>
+          </a:fillRef>
+          <a:effectRef idx="2">
+            <a:schemeClr val="accent1"/>
+          </a:effectRef>
+          <a:fontRef idx="minor">
+            <a:schemeClr val="lt1"/>
+          </a:fontRef>
+        </p:style>
+        <p:txBody>
+          <a:bodyPr rtlCol="0" anchor="ctr"/>
+          <a:lstStyle/>
+          <a:p>
+            <a:pPr algn="ctr"/>
+          </a:p>
+        </p:txBody>
+      </p:sp>
+      <p:sp>
+        <p:nvSpPr>
+          <p:cNvPr id="23" name="logo-4"/>
+          <p:cNvSpPr/>
+          <p:nvPr/>
+        </p:nvSpPr>
+        <p:spPr>
+          <a:xfrm>
+            <a:off x="550031" y="4908931"/>
+            <a:ext cx="43572" cy="50292"/>
+          </a:xfrm>
+          <a:custGeom>
+            <a:avLst/>
+            <a:gdLst/>
+            <a:ahLst/>
+            <a:cxnLst/>
+            <a:rect l="l" t="t" r="r" b="b"/>
+            <a:pathLst>
+              <a:path w="43572" h="50292">
+                <a:moveTo>
+                  <a:pt x="21786" y="0"/>
+                </a:moveTo>
+                <a:lnTo>
+                  <a:pt x="43572" y="12573"/>
+                </a:lnTo>
+                <a:lnTo>
+                  <a:pt x="43572" y="37719"/>
+                </a:lnTo>
+                <a:lnTo>
+                  <a:pt x="21786" y="50292"/>
+                </a:lnTo>
+                <a:lnTo>
+                  <a:pt x="0" y="37719"/>
+                </a:lnTo>
+                <a:lnTo>
+                  <a:pt x="0" y="12573"/>
+                </a:lnTo>
+                <a:close/>
+              </a:path>
+            </a:pathLst>
+          </a:custGeom>
+          <a:solidFill>
+            <a:srgbClr val="111111"/>
+          </a:solidFill>
+          <a:ln>
+            <a:noFill/>
+          </a:ln>
+          <a:effectLst/>
+        </p:spPr>
+        <p:style>
+          <a:lnRef idx="1">
+            <a:schemeClr val="accent1"/>
+          </a:lnRef>
+          <a:fillRef idx="3">
+            <a:schemeClr val="accent1"/>
+          </a:fillRef>
+          <a:effectRef idx="2">
+            <a:schemeClr val="accent1"/>
+          </a:effectRef>
+          <a:fontRef idx="minor">
+            <a:schemeClr val="lt1"/>
+          </a:fontRef>
+        </p:style>
+        <p:txBody>
+          <a:bodyPr rtlCol="0" anchor="ctr"/>
+          <a:lstStyle/>
+          <a:p>
+            <a:pPr algn="ctr"/>
+          </a:p>
+        </p:txBody>
+      </p:sp>
+      <p:sp>
+        <p:nvSpPr>
+          <p:cNvPr id="24" name="logo-5"/>
+          <p:cNvSpPr/>
+          <p:nvPr/>
+        </p:nvSpPr>
+        <p:spPr>
+          <a:xfrm>
+            <a:off x="498596" y="4908931"/>
+            <a:ext cx="43572" cy="50292"/>
+          </a:xfrm>
+          <a:custGeom>
+            <a:avLst/>
+            <a:gdLst/>
+            <a:ahLst/>
+            <a:cxnLst/>
+            <a:rect l="l" t="t" r="r" b="b"/>
+            <a:pathLst>
+              <a:path w="43572" h="50292">
+                <a:moveTo>
+                  <a:pt x="21786" y="0"/>
+                </a:moveTo>
+                <a:lnTo>
+                  <a:pt x="43572" y="12573"/>
+                </a:lnTo>
+                <a:lnTo>
+                  <a:pt x="43572" y="37719"/>
+                </a:lnTo>
+                <a:lnTo>
+                  <a:pt x="21786" y="50292"/>
+                </a:lnTo>
+                <a:lnTo>
+                  <a:pt x="0" y="37719"/>
+                </a:lnTo>
+                <a:lnTo>
+                  <a:pt x="0" y="12573"/>
+                </a:lnTo>
+                <a:close/>
+              </a:path>
+            </a:pathLst>
+          </a:custGeom>
+          <a:solidFill>
+            <a:srgbClr val="111111"/>
+          </a:solidFill>
+          <a:ln>
+            <a:noFill/>
+          </a:ln>
+          <a:effectLst/>
+        </p:spPr>
+        <p:style>
+          <a:lnRef idx="1">
+            <a:schemeClr val="accent1"/>
+          </a:lnRef>
+          <a:fillRef idx="3">
+            <a:schemeClr val="accent1"/>
+          </a:fillRef>
+          <a:effectRef idx="2">
+            <a:schemeClr val="accent1"/>
+          </a:effectRef>
+          <a:fontRef idx="minor">
+            <a:schemeClr val="lt1"/>
+          </a:fontRef>
+        </p:style>
+        <p:txBody>
+          <a:bodyPr rtlCol="0" anchor="ctr"/>
+          <a:lstStyle/>
+          <a:p>
+            <a:pPr algn="ctr"/>
+          </a:p>
+        </p:txBody>
+      </p:sp>
+      <p:sp>
+        <p:nvSpPr>
+          <p:cNvPr id="26" name="logo-center"/>
+          <p:cNvSpPr/>
+          <p:nvPr/>
+        </p:nvSpPr>
+        <p:spPr>
+          <a:xfrm>
+            <a:off x="524314" y="4864354"/>
+            <a:ext cx="43571" cy="50292"/>
+          </a:xfrm>
+          <a:custGeom>
+            <a:avLst/>
+            <a:gdLst/>
+            <a:ahLst/>
+            <a:cxnLst/>
+            <a:rect l="l" t="t" r="r" b="b"/>
+            <a:pathLst>
+              <a:path w="43571" h="50292">
+                <a:moveTo>
+                  <a:pt x="21786" y="0"/>
+                </a:moveTo>
+                <a:lnTo>
+                  <a:pt x="43571" y="12573"/>
+                </a:lnTo>
+                <a:lnTo>
+                  <a:pt x="43571" y="37719"/>
+                </a:lnTo>
+                <a:lnTo>
+                  <a:pt x="21786" y="50292"/>
+                </a:lnTo>
+                <a:lnTo>
+                  <a:pt x="0" y="37719"/>
+                </a:lnTo>
+                <a:lnTo>
+                  <a:pt x="0" y="12573"/>
+                </a:lnTo>
+                <a:close/>
+              </a:path>
+            </a:pathLst>
+          </a:custGeom>
+          <a:solidFill>
+            <a:srgbClr val="E2001A"/>
+          </a:solidFill>
+          <a:ln>
+            <a:noFill/>
+          </a:ln>
+          <a:effectLst/>
+        </p:spPr>
+        <p:style>
+          <a:lnRef idx="1">
+            <a:schemeClr val="accent1"/>
+          </a:lnRef>
+          <a:fillRef idx="3">
+            <a:schemeClr val="accent1"/>
+          </a:fillRef>
+          <a:effectRef idx="2">
+            <a:schemeClr val="accent1"/>
+          </a:effectRef>
+          <a:fontRef idx="minor">
+            <a:schemeClr val="lt1"/>
+          </a:fontRef>
+        </p:style>
+        <p:txBody>
+          <a:bodyPr rtlCol="0" anchor="ctr"/>
+          <a:lstStyle/>
+          <a:p>
+            <a:pPr algn="ctr"/>
           </a:p>
         </p:txBody>
       </p:sp>
@@ -2650,12 +3147,12 @@
               <a:buNone/>
             </a:pPr>
             <a:r>
-              <a:rPr lang="en-US" sz="5400" b="1" dirty="0">
-                <a:solidFill>
-                  <a:schemeClr val="bg1"/>
-                </a:solidFill>
-              </a:rPr>
-              <a:t>HiveVoice</a:t>
+              <a:rPr b="1" sz="5400"/>
+              <a:t>hive</a:t>
+            </a:r>
+            <a:r>
+              <a:rPr b="0" sz="5400"/>
+              <a:t>voice</a:t>
             </a:r>
             <a:endParaRPr lang="en-US" sz="5400" dirty="0"/>
           </a:p>
@@ -2701,203 +3198,500 @@
       </p:sp>
       <p:sp>
         <p:nvSpPr>
-          <p:cNvPr id="4" name="hex-0"/>
+          <p:cNvPr id="4" name="logo-0"/>
           <p:cNvSpPr/>
           <p:nvPr/>
         </p:nvSpPr>
         <p:spPr>
           <a:xfrm>
-            <a:off x="5852160" y="914400"/>
-            <a:ext cx="914400" cy="791870"/>
-          </a:xfrm>
-          <a:prstGeom prst="hexagon">
-            <a:avLst/>
-          </a:prstGeom>
+            <a:off x="7540269" y="1859280"/>
+            <a:ext cx="629361" cy="726440"/>
+          </a:xfrm>
+          <a:custGeom>
+            <a:avLst/>
+            <a:gdLst/>
+            <a:ahLst/>
+            <a:cxnLst/>
+            <a:rect l="l" t="t" r="r" b="b"/>
+            <a:pathLst>
+              <a:path w="629361" h="726440">
+                <a:moveTo>
+                  <a:pt x="314681" y="0"/>
+                </a:moveTo>
+                <a:lnTo>
+                  <a:pt x="629361" y="181609"/>
+                </a:lnTo>
+                <a:lnTo>
+                  <a:pt x="629361" y="544830"/>
+                </a:lnTo>
+                <a:lnTo>
+                  <a:pt x="314681" y="726440"/>
+                </a:lnTo>
+                <a:lnTo>
+                  <a:pt x="0" y="544830"/>
+                </a:lnTo>
+                <a:lnTo>
+                  <a:pt x="0" y="181609"/>
+                </a:lnTo>
+                <a:close/>
+              </a:path>
+            </a:pathLst>
+          </a:custGeom>
           <a:solidFill>
-            <a:srgbClr val="FFFFFF"/>
+            <a:srgbClr val="F4F4F4"/>
           </a:solidFill>
-          <a:ln w="6350">
-            <a:solidFill>
-              <a:srgbClr val="FFFFFF"/>
-            </a:solidFill>
-            <a:prstDash val="solid"/>
+          <a:ln>
+            <a:noFill/>
           </a:ln>
-        </p:spPr>
-      </p:sp>
-      <p:sp>
-        <p:nvSpPr>
-          <p:cNvPr id="5" name="hex-1"/>
+          <a:effectLst/>
+        </p:spPr>
+        <p:style>
+          <a:lnRef idx="1">
+            <a:schemeClr val="accent1"/>
+          </a:lnRef>
+          <a:fillRef idx="3">
+            <a:schemeClr val="accent1"/>
+          </a:fillRef>
+          <a:effectRef idx="2">
+            <a:schemeClr val="accent1"/>
+          </a:effectRef>
+          <a:fontRef idx="minor">
+            <a:schemeClr val="lt1"/>
+          </a:fontRef>
+        </p:style>
+        <p:txBody>
+          <a:bodyPr rtlCol="0" anchor="ctr"/>
+          <a:lstStyle/>
+          <a:p>
+            <a:pPr algn="ctr"/>
+          </a:p>
+        </p:txBody>
+      </p:sp>
+      <p:sp>
+        <p:nvSpPr>
+          <p:cNvPr id="5" name="logo-1"/>
           <p:cNvSpPr/>
           <p:nvPr/>
         </p:nvSpPr>
         <p:spPr>
           <a:xfrm>
-            <a:off x="6601968" y="1346911"/>
-            <a:ext cx="914400" cy="791870"/>
-          </a:xfrm>
-          <a:prstGeom prst="hexagon">
-            <a:avLst/>
-          </a:prstGeom>
+            <a:off x="6054369" y="1859280"/>
+            <a:ext cx="629361" cy="726440"/>
+          </a:xfrm>
+          <a:custGeom>
+            <a:avLst/>
+            <a:gdLst/>
+            <a:ahLst/>
+            <a:cxnLst/>
+            <a:rect l="l" t="t" r="r" b="b"/>
+            <a:pathLst>
+              <a:path w="629361" h="726440">
+                <a:moveTo>
+                  <a:pt x="314681" y="0"/>
+                </a:moveTo>
+                <a:lnTo>
+                  <a:pt x="629361" y="181609"/>
+                </a:lnTo>
+                <a:lnTo>
+                  <a:pt x="629361" y="544830"/>
+                </a:lnTo>
+                <a:lnTo>
+                  <a:pt x="314681" y="726440"/>
+                </a:lnTo>
+                <a:lnTo>
+                  <a:pt x="0" y="544830"/>
+                </a:lnTo>
+                <a:lnTo>
+                  <a:pt x="0" y="181609"/>
+                </a:lnTo>
+                <a:close/>
+              </a:path>
+            </a:pathLst>
+          </a:custGeom>
           <a:solidFill>
-            <a:srgbClr val="FFFFFF"/>
+            <a:srgbClr val="F4F4F4"/>
           </a:solidFill>
-          <a:ln w="6350">
-            <a:solidFill>
-              <a:srgbClr val="FFFFFF"/>
-            </a:solidFill>
-            <a:prstDash val="solid"/>
+          <a:ln>
+            <a:noFill/>
           </a:ln>
-        </p:spPr>
-      </p:sp>
-      <p:sp>
-        <p:nvSpPr>
-          <p:cNvPr id="6" name="hex-2"/>
+          <a:effectLst/>
+        </p:spPr>
+        <p:style>
+          <a:lnRef idx="1">
+            <a:schemeClr val="accent1"/>
+          </a:lnRef>
+          <a:fillRef idx="3">
+            <a:schemeClr val="accent1"/>
+          </a:fillRef>
+          <a:effectRef idx="2">
+            <a:schemeClr val="accent1"/>
+          </a:effectRef>
+          <a:fontRef idx="minor">
+            <a:schemeClr val="lt1"/>
+          </a:fontRef>
+        </p:style>
+        <p:txBody>
+          <a:bodyPr rtlCol="0" anchor="ctr"/>
+          <a:lstStyle/>
+          <a:p>
+            <a:pPr algn="ctr"/>
+          </a:p>
+        </p:txBody>
+      </p:sp>
+      <p:sp>
+        <p:nvSpPr>
+          <p:cNvPr id="6" name="logo-2"/>
           <p:cNvSpPr/>
           <p:nvPr/>
         </p:nvSpPr>
         <p:spPr>
           <a:xfrm>
-            <a:off x="7351776" y="914400"/>
-            <a:ext cx="914400" cy="791870"/>
-          </a:xfrm>
-          <a:prstGeom prst="hexagon">
-            <a:avLst/>
-          </a:prstGeom>
+            <a:off x="7168794" y="1215390"/>
+            <a:ext cx="629361" cy="726440"/>
+          </a:xfrm>
+          <a:custGeom>
+            <a:avLst/>
+            <a:gdLst/>
+            <a:ahLst/>
+            <a:cxnLst/>
+            <a:rect l="l" t="t" r="r" b="b"/>
+            <a:pathLst>
+              <a:path w="629361" h="726440">
+                <a:moveTo>
+                  <a:pt x="314681" y="0"/>
+                </a:moveTo>
+                <a:lnTo>
+                  <a:pt x="629361" y="181610"/>
+                </a:lnTo>
+                <a:lnTo>
+                  <a:pt x="629361" y="544830"/>
+                </a:lnTo>
+                <a:lnTo>
+                  <a:pt x="314681" y="726440"/>
+                </a:lnTo>
+                <a:lnTo>
+                  <a:pt x="0" y="544830"/>
+                </a:lnTo>
+                <a:lnTo>
+                  <a:pt x="0" y="181610"/>
+                </a:lnTo>
+                <a:close/>
+              </a:path>
+            </a:pathLst>
+          </a:custGeom>
+          <a:solidFill>
+            <a:srgbClr val="F4F4F4"/>
+          </a:solidFill>
+          <a:ln>
+            <a:noFill/>
+          </a:ln>
+          <a:effectLst/>
+        </p:spPr>
+        <p:style>
+          <a:lnRef idx="1">
+            <a:schemeClr val="accent1"/>
+          </a:lnRef>
+          <a:fillRef idx="3">
+            <a:schemeClr val="accent1"/>
+          </a:fillRef>
+          <a:effectRef idx="2">
+            <a:schemeClr val="accent1"/>
+          </a:effectRef>
+          <a:fontRef idx="minor">
+            <a:schemeClr val="lt1"/>
+          </a:fontRef>
+        </p:style>
+        <p:txBody>
+          <a:bodyPr rtlCol="0" anchor="ctr"/>
+          <a:lstStyle/>
+          <a:p>
+            <a:pPr algn="ctr"/>
+          </a:p>
+        </p:txBody>
+      </p:sp>
+      <p:sp>
+        <p:nvSpPr>
+          <p:cNvPr id="7" name="logo-3"/>
+          <p:cNvSpPr/>
+          <p:nvPr/>
+        </p:nvSpPr>
+        <p:spPr>
+          <a:xfrm>
+            <a:off x="6425844" y="1215390"/>
+            <a:ext cx="629361" cy="726440"/>
+          </a:xfrm>
+          <a:custGeom>
+            <a:avLst/>
+            <a:gdLst/>
+            <a:ahLst/>
+            <a:cxnLst/>
+            <a:rect l="l" t="t" r="r" b="b"/>
+            <a:pathLst>
+              <a:path w="629361" h="726440">
+                <a:moveTo>
+                  <a:pt x="314681" y="0"/>
+                </a:moveTo>
+                <a:lnTo>
+                  <a:pt x="629361" y="181610"/>
+                </a:lnTo>
+                <a:lnTo>
+                  <a:pt x="629361" y="544830"/>
+                </a:lnTo>
+                <a:lnTo>
+                  <a:pt x="314681" y="726440"/>
+                </a:lnTo>
+                <a:lnTo>
+                  <a:pt x="0" y="544830"/>
+                </a:lnTo>
+                <a:lnTo>
+                  <a:pt x="0" y="181610"/>
+                </a:lnTo>
+                <a:close/>
+              </a:path>
+            </a:pathLst>
+          </a:custGeom>
+          <a:solidFill>
+            <a:srgbClr val="F4F4F4"/>
+          </a:solidFill>
+          <a:ln>
+            <a:noFill/>
+          </a:ln>
+          <a:effectLst/>
+        </p:spPr>
+        <p:style>
+          <a:lnRef idx="1">
+            <a:schemeClr val="accent1"/>
+          </a:lnRef>
+          <a:fillRef idx="3">
+            <a:schemeClr val="accent1"/>
+          </a:fillRef>
+          <a:effectRef idx="2">
+            <a:schemeClr val="accent1"/>
+          </a:effectRef>
+          <a:fontRef idx="minor">
+            <a:schemeClr val="lt1"/>
+          </a:fontRef>
+        </p:style>
+        <p:txBody>
+          <a:bodyPr rtlCol="0" anchor="ctr"/>
+          <a:lstStyle/>
+          <a:p>
+            <a:pPr algn="ctr"/>
+          </a:p>
+        </p:txBody>
+      </p:sp>
+      <p:sp>
+        <p:nvSpPr>
+          <p:cNvPr id="8" name="logo-4"/>
+          <p:cNvSpPr/>
+          <p:nvPr/>
+        </p:nvSpPr>
+        <p:spPr>
+          <a:xfrm>
+            <a:off x="7168794" y="2503170"/>
+            <a:ext cx="629361" cy="726440"/>
+          </a:xfrm>
+          <a:custGeom>
+            <a:avLst/>
+            <a:gdLst/>
+            <a:ahLst/>
+            <a:cxnLst/>
+            <a:rect l="l" t="t" r="r" b="b"/>
+            <a:pathLst>
+              <a:path w="629361" h="726440">
+                <a:moveTo>
+                  <a:pt x="314681" y="0"/>
+                </a:moveTo>
+                <a:lnTo>
+                  <a:pt x="629361" y="181610"/>
+                </a:lnTo>
+                <a:lnTo>
+                  <a:pt x="629361" y="544830"/>
+                </a:lnTo>
+                <a:lnTo>
+                  <a:pt x="314681" y="726440"/>
+                </a:lnTo>
+                <a:lnTo>
+                  <a:pt x="0" y="544830"/>
+                </a:lnTo>
+                <a:lnTo>
+                  <a:pt x="0" y="181610"/>
+                </a:lnTo>
+                <a:close/>
+              </a:path>
+            </a:pathLst>
+          </a:custGeom>
+          <a:solidFill>
+            <a:srgbClr val="F4F4F4"/>
+          </a:solidFill>
+          <a:ln>
+            <a:noFill/>
+          </a:ln>
+          <a:effectLst/>
+        </p:spPr>
+        <p:style>
+          <a:lnRef idx="1">
+            <a:schemeClr val="accent1"/>
+          </a:lnRef>
+          <a:fillRef idx="3">
+            <a:schemeClr val="accent1"/>
+          </a:fillRef>
+          <a:effectRef idx="2">
+            <a:schemeClr val="accent1"/>
+          </a:effectRef>
+          <a:fontRef idx="minor">
+            <a:schemeClr val="lt1"/>
+          </a:fontRef>
+        </p:style>
+        <p:txBody>
+          <a:bodyPr rtlCol="0" anchor="ctr"/>
+          <a:lstStyle/>
+          <a:p>
+            <a:pPr algn="ctr"/>
+          </a:p>
+        </p:txBody>
+      </p:sp>
+      <p:sp>
+        <p:nvSpPr>
+          <p:cNvPr id="9" name="logo-5"/>
+          <p:cNvSpPr/>
+          <p:nvPr/>
+        </p:nvSpPr>
+        <p:spPr>
+          <a:xfrm>
+            <a:off x="6425844" y="2503170"/>
+            <a:ext cx="629361" cy="726440"/>
+          </a:xfrm>
+          <a:custGeom>
+            <a:avLst/>
+            <a:gdLst/>
+            <a:ahLst/>
+            <a:cxnLst/>
+            <a:rect l="l" t="t" r="r" b="b"/>
+            <a:pathLst>
+              <a:path w="629361" h="726440">
+                <a:moveTo>
+                  <a:pt x="314681" y="0"/>
+                </a:moveTo>
+                <a:lnTo>
+                  <a:pt x="629361" y="181610"/>
+                </a:lnTo>
+                <a:lnTo>
+                  <a:pt x="629361" y="544830"/>
+                </a:lnTo>
+                <a:lnTo>
+                  <a:pt x="314681" y="726440"/>
+                </a:lnTo>
+                <a:lnTo>
+                  <a:pt x="0" y="544830"/>
+                </a:lnTo>
+                <a:lnTo>
+                  <a:pt x="0" y="181610"/>
+                </a:lnTo>
+                <a:close/>
+              </a:path>
+            </a:pathLst>
+          </a:custGeom>
+          <a:solidFill>
+            <a:srgbClr val="F4F4F4"/>
+          </a:solidFill>
+          <a:ln>
+            <a:noFill/>
+          </a:ln>
+          <a:effectLst/>
+        </p:spPr>
+        <p:style>
+          <a:lnRef idx="1">
+            <a:schemeClr val="accent1"/>
+          </a:lnRef>
+          <a:fillRef idx="3">
+            <a:schemeClr val="accent1"/>
+          </a:fillRef>
+          <a:effectRef idx="2">
+            <a:schemeClr val="accent1"/>
+          </a:effectRef>
+          <a:fontRef idx="minor">
+            <a:schemeClr val="lt1"/>
+          </a:fontRef>
+        </p:style>
+        <p:txBody>
+          <a:bodyPr rtlCol="0" anchor="ctr"/>
+          <a:lstStyle/>
+          <a:p>
+            <a:pPr algn="ctr"/>
+          </a:p>
+        </p:txBody>
+      </p:sp>
+      <p:sp>
+        <p:nvSpPr>
+          <p:cNvPr id="10" name="logo-center"/>
+          <p:cNvSpPr/>
+          <p:nvPr/>
+        </p:nvSpPr>
+        <p:spPr>
+          <a:xfrm>
+            <a:off x="6797319" y="1859280"/>
+            <a:ext cx="629361" cy="726440"/>
+          </a:xfrm>
+          <a:custGeom>
+            <a:avLst/>
+            <a:gdLst/>
+            <a:ahLst/>
+            <a:cxnLst/>
+            <a:rect l="l" t="t" r="r" b="b"/>
+            <a:pathLst>
+              <a:path w="629361" h="726440">
+                <a:moveTo>
+                  <a:pt x="314681" y="0"/>
+                </a:moveTo>
+                <a:lnTo>
+                  <a:pt x="629361" y="181609"/>
+                </a:lnTo>
+                <a:lnTo>
+                  <a:pt x="629361" y="544830"/>
+                </a:lnTo>
+                <a:lnTo>
+                  <a:pt x="314681" y="726440"/>
+                </a:lnTo>
+                <a:lnTo>
+                  <a:pt x="0" y="544830"/>
+                </a:lnTo>
+                <a:lnTo>
+                  <a:pt x="0" y="181609"/>
+                </a:lnTo>
+                <a:close/>
+              </a:path>
+            </a:pathLst>
+          </a:custGeom>
           <a:solidFill>
             <a:srgbClr val="E2001A"/>
           </a:solidFill>
-          <a:ln w="6350">
-            <a:solidFill>
-              <a:srgbClr val="E2001A"/>
-            </a:solidFill>
-            <a:prstDash val="solid"/>
+          <a:ln>
+            <a:noFill/>
           </a:ln>
-        </p:spPr>
-      </p:sp>
-      <p:sp>
-        <p:nvSpPr>
-          <p:cNvPr id="7" name="hex-3"/>
-          <p:cNvSpPr/>
-          <p:nvPr/>
-        </p:nvSpPr>
-        <p:spPr>
-          <a:xfrm>
-            <a:off x="5852160" y="1779422"/>
-            <a:ext cx="914400" cy="791870"/>
-          </a:xfrm>
-          <a:prstGeom prst="hexagon">
-            <a:avLst/>
-          </a:prstGeom>
-          <a:solidFill>
-            <a:srgbClr val="FFFFFF"/>
-          </a:solidFill>
-          <a:ln w="6350">
-            <a:solidFill>
-              <a:srgbClr val="FFFFFF"/>
-            </a:solidFill>
-            <a:prstDash val="solid"/>
-          </a:ln>
-        </p:spPr>
-      </p:sp>
-      <p:sp>
-        <p:nvSpPr>
-          <p:cNvPr id="8" name="hex-4"/>
-          <p:cNvSpPr/>
-          <p:nvPr/>
-        </p:nvSpPr>
-        <p:spPr>
-          <a:xfrm>
-            <a:off x="6601968" y="2211934"/>
-            <a:ext cx="914400" cy="791870"/>
-          </a:xfrm>
-          <a:prstGeom prst="hexagon">
-            <a:avLst/>
-          </a:prstGeom>
-          <a:solidFill>
-            <a:srgbClr val="FFFFFF"/>
-          </a:solidFill>
-          <a:ln w="6350">
-            <a:solidFill>
-              <a:srgbClr val="FFFFFF"/>
-            </a:solidFill>
-            <a:prstDash val="solid"/>
-          </a:ln>
-        </p:spPr>
-      </p:sp>
-      <p:sp>
-        <p:nvSpPr>
-          <p:cNvPr id="9" name="hex-5"/>
-          <p:cNvSpPr/>
-          <p:nvPr/>
-        </p:nvSpPr>
-        <p:spPr>
-          <a:xfrm>
-            <a:off x="7351776" y="1779422"/>
-            <a:ext cx="914400" cy="791870"/>
-          </a:xfrm>
-          <a:prstGeom prst="hexagon">
-            <a:avLst/>
-          </a:prstGeom>
-          <a:solidFill>
-            <a:srgbClr val="FFFFFF"/>
-          </a:solidFill>
-          <a:ln w="6350">
-            <a:solidFill>
-              <a:srgbClr val="FFFFFF"/>
-            </a:solidFill>
-            <a:prstDash val="solid"/>
-          </a:ln>
-        </p:spPr>
-      </p:sp>
-      <p:sp>
-        <p:nvSpPr>
-          <p:cNvPr id="10" name="hex-6"/>
-          <p:cNvSpPr/>
-          <p:nvPr/>
-        </p:nvSpPr>
-        <p:spPr>
-          <a:xfrm>
-            <a:off x="6601968" y="3076956"/>
-            <a:ext cx="914400" cy="791870"/>
-          </a:xfrm>
-          <a:prstGeom prst="hexagon">
-            <a:avLst/>
-          </a:prstGeom>
-          <a:solidFill>
-            <a:srgbClr val="FFFFFF"/>
-          </a:solidFill>
-          <a:ln w="6350">
-            <a:solidFill>
-              <a:srgbClr val="FFFFFF"/>
-            </a:solidFill>
-            <a:prstDash val="solid"/>
-          </a:ln>
-        </p:spPr>
-      </p:sp>
-      <p:sp>
-        <p:nvSpPr>
-          <p:cNvPr id="11" name="hex-7"/>
-          <p:cNvSpPr/>
-          <p:nvPr/>
-        </p:nvSpPr>
-        <p:spPr>
-          <a:xfrm>
-            <a:off x="5852160" y="2644445"/>
-            <a:ext cx="914400" cy="791870"/>
-          </a:xfrm>
-          <a:prstGeom prst="hexagon">
-            <a:avLst/>
-          </a:prstGeom>
-          <a:solidFill>
-            <a:srgbClr val="FFFFFF"/>
-          </a:solidFill>
-          <a:ln w="6350">
-            <a:solidFill>
-              <a:srgbClr val="FFFFFF"/>
-            </a:solidFill>
-            <a:prstDash val="solid"/>
-          </a:ln>
-        </p:spPr>
+          <a:effectLst/>
+        </p:spPr>
+        <p:style>
+          <a:lnRef idx="1">
+            <a:schemeClr val="accent1"/>
+          </a:lnRef>
+          <a:fillRef idx="3">
+            <a:schemeClr val="accent1"/>
+          </a:fillRef>
+          <a:effectRef idx="2">
+            <a:schemeClr val="accent1"/>
+          </a:effectRef>
+          <a:fontRef idx="minor">
+            <a:schemeClr val="lt1"/>
+          </a:fontRef>
+        </p:style>
+        <p:txBody>
+          <a:bodyPr rtlCol="0" anchor="ctr"/>
+          <a:lstStyle/>
+          <a:p>
+            <a:pPr algn="ctr"/>
+          </a:p>
+        </p:txBody>
       </p:sp>
     </p:spTree>
   </p:cSld>
@@ -3827,7 +4621,7 @@
         <p:spPr>
           <a:xfrm>
             <a:off x="4937760" y="3017520"/>
-            <a:ext cx="3474720" cy="1371600"/>
+            <a:ext cx="3474720" cy="838200"/>
           </a:xfrm>
           <a:prstGeom prst="rect">
             <a:avLst/>
@@ -3848,7 +4642,7 @@
                   <a:schemeClr val="tx1"/>
                 </a:solidFill>
               </a:rPr>
-              <a:t>Abholungen als Aufgaben, Brot als kostenloses Angebot auf der Karte, per „Weitergeben“ sofort im Nachbarschafts-Chat.</a:t>
+              <a:t>Abholungen als Aufgaben, Brot gratis auf der Karte, per „Weitergeben“ sofort im Nachbarschafts-Chat.</a:t>
             </a:r>
             <a:endParaRPr lang="en-US" sz="1400" dirty="0"/>
           </a:p>
@@ -3896,6 +4690,91 @@
               <a:t>11</a:t>
             </a:fld>
             <a:endParaRPr lang="en-US"/>
+          </a:p>
+        </p:txBody>
+      </p:sp>
+      <p:sp>
+        <p:nvSpPr>
+          <p:cNvPr id="26" name="fact-bar-4-1"/>
+          <p:cNvSpPr/>
+          <p:nvPr/>
+        </p:nvSpPr>
+        <p:spPr>
+          <a:xfrm>
+            <a:off x="4937760" y="3911600"/>
+            <a:ext cx="38100" cy="482600"/>
+          </a:xfrm>
+          <a:prstGeom prst="rect">
+            <a:avLst/>
+          </a:prstGeom>
+          <a:solidFill>
+            <a:srgbClr val="E2001A"/>
+          </a:solidFill>
+          <a:ln>
+            <a:noFill/>
+          </a:ln>
+          <a:effectLst/>
+        </p:spPr>
+        <p:style>
+          <a:lnRef idx="1">
+            <a:schemeClr val="accent1"/>
+          </a:lnRef>
+          <a:fillRef idx="3">
+            <a:schemeClr val="accent1"/>
+          </a:fillRef>
+          <a:effectRef idx="2">
+            <a:schemeClr val="accent1"/>
+          </a:effectRef>
+          <a:fontRef idx="minor">
+            <a:schemeClr val="lt1"/>
+          </a:fontRef>
+        </p:style>
+        <p:txBody>
+          <a:bodyPr rtlCol="0" anchor="ctr"/>
+          <a:lstStyle/>
+          <a:p>
+            <a:pPr algn="ctr"/>
+          </a:p>
+        </p:txBody>
+      </p:sp>
+      <p:sp>
+        <p:nvSpPr>
+          <p:cNvPr id="27" name="fact-4-1"/>
+          <p:cNvSpPr txBox="1"/>
+          <p:nvPr/>
+        </p:nvSpPr>
+        <p:spPr>
+          <a:xfrm>
+            <a:off x="5064760" y="3911600"/>
+            <a:ext cx="3347720" cy="482600"/>
+          </a:xfrm>
+          <a:prstGeom prst="rect">
+            <a:avLst/>
+          </a:prstGeom>
+          <a:noFill/>
+        </p:spPr>
+        <p:txBody>
+          <a:bodyPr wrap="square" lIns="0" rIns="0" tIns="0" bIns="0">
+            <a:spAutoFit/>
+          </a:bodyPr>
+          <a:lstStyle/>
+          <a:p>
+            <a:r>
+              <a:rPr sz="900" b="1">
+                <a:solidFill>
+                  <a:srgbClr val="E2001A"/>
+                </a:solidFill>
+              </a:rPr>
+              <a:t>EUROPA  </a:t>
+            </a:r>
+            <a:r>
+              <a:rPr sz="1000">
+                <a:solidFill>
+                  <a:srgbClr val="555555"/>
+                </a:solidFill>
+              </a:rPr>
+              <a:t>58 Mio. Tonnen Lebensmittelabfall im Jahr, 130 kg pro Kopf (Eurostat, 2023)</a:t>
+            </a:r>
           </a:p>
         </p:txBody>
       </p:sp>
@@ -8062,203 +8941,500 @@
       </p:sp>
       <p:sp>
         <p:nvSpPr>
-          <p:cNvPr id="4" name="hex-0"/>
+          <p:cNvPr id="4" name="logo-0"/>
           <p:cNvSpPr/>
           <p:nvPr/>
         </p:nvSpPr>
         <p:spPr>
           <a:xfrm>
-            <a:off x="5852160" y="914400"/>
-            <a:ext cx="914400" cy="791870"/>
-          </a:xfrm>
-          <a:prstGeom prst="hexagon">
-            <a:avLst/>
-          </a:prstGeom>
+            <a:off x="7540269" y="1859280"/>
+            <a:ext cx="629361" cy="726440"/>
+          </a:xfrm>
+          <a:custGeom>
+            <a:avLst/>
+            <a:gdLst/>
+            <a:ahLst/>
+            <a:cxnLst/>
+            <a:rect l="l" t="t" r="r" b="b"/>
+            <a:pathLst>
+              <a:path w="629361" h="726440">
+                <a:moveTo>
+                  <a:pt x="314681" y="0"/>
+                </a:moveTo>
+                <a:lnTo>
+                  <a:pt x="629361" y="181609"/>
+                </a:lnTo>
+                <a:lnTo>
+                  <a:pt x="629361" y="544830"/>
+                </a:lnTo>
+                <a:lnTo>
+                  <a:pt x="314681" y="726440"/>
+                </a:lnTo>
+                <a:lnTo>
+                  <a:pt x="0" y="544830"/>
+                </a:lnTo>
+                <a:lnTo>
+                  <a:pt x="0" y="181609"/>
+                </a:lnTo>
+                <a:close/>
+              </a:path>
+            </a:pathLst>
+          </a:custGeom>
           <a:solidFill>
-            <a:srgbClr val="FFFFFF"/>
+            <a:srgbClr val="F4F4F4"/>
           </a:solidFill>
-          <a:ln w="6350">
-            <a:solidFill>
-              <a:srgbClr val="FFFFFF"/>
-            </a:solidFill>
-            <a:prstDash val="solid"/>
+          <a:ln>
+            <a:noFill/>
           </a:ln>
-        </p:spPr>
-      </p:sp>
-      <p:sp>
-        <p:nvSpPr>
-          <p:cNvPr id="5" name="hex-1"/>
+          <a:effectLst/>
+        </p:spPr>
+        <p:style>
+          <a:lnRef idx="1">
+            <a:schemeClr val="accent1"/>
+          </a:lnRef>
+          <a:fillRef idx="3">
+            <a:schemeClr val="accent1"/>
+          </a:fillRef>
+          <a:effectRef idx="2">
+            <a:schemeClr val="accent1"/>
+          </a:effectRef>
+          <a:fontRef idx="minor">
+            <a:schemeClr val="lt1"/>
+          </a:fontRef>
+        </p:style>
+        <p:txBody>
+          <a:bodyPr rtlCol="0" anchor="ctr"/>
+          <a:lstStyle/>
+          <a:p>
+            <a:pPr algn="ctr"/>
+          </a:p>
+        </p:txBody>
+      </p:sp>
+      <p:sp>
+        <p:nvSpPr>
+          <p:cNvPr id="5" name="logo-1"/>
           <p:cNvSpPr/>
           <p:nvPr/>
         </p:nvSpPr>
         <p:spPr>
           <a:xfrm>
-            <a:off x="6601968" y="1346911"/>
-            <a:ext cx="914400" cy="791870"/>
-          </a:xfrm>
-          <a:prstGeom prst="hexagon">
-            <a:avLst/>
-          </a:prstGeom>
+            <a:off x="6054369" y="1859280"/>
+            <a:ext cx="629361" cy="726440"/>
+          </a:xfrm>
+          <a:custGeom>
+            <a:avLst/>
+            <a:gdLst/>
+            <a:ahLst/>
+            <a:cxnLst/>
+            <a:rect l="l" t="t" r="r" b="b"/>
+            <a:pathLst>
+              <a:path w="629361" h="726440">
+                <a:moveTo>
+                  <a:pt x="314681" y="0"/>
+                </a:moveTo>
+                <a:lnTo>
+                  <a:pt x="629361" y="181609"/>
+                </a:lnTo>
+                <a:lnTo>
+                  <a:pt x="629361" y="544830"/>
+                </a:lnTo>
+                <a:lnTo>
+                  <a:pt x="314681" y="726440"/>
+                </a:lnTo>
+                <a:lnTo>
+                  <a:pt x="0" y="544830"/>
+                </a:lnTo>
+                <a:lnTo>
+                  <a:pt x="0" y="181609"/>
+                </a:lnTo>
+                <a:close/>
+              </a:path>
+            </a:pathLst>
+          </a:custGeom>
           <a:solidFill>
-            <a:srgbClr val="FFFFFF"/>
+            <a:srgbClr val="F4F4F4"/>
           </a:solidFill>
-          <a:ln w="6350">
-            <a:solidFill>
-              <a:srgbClr val="FFFFFF"/>
-            </a:solidFill>
-            <a:prstDash val="solid"/>
+          <a:ln>
+            <a:noFill/>
           </a:ln>
-        </p:spPr>
-      </p:sp>
-      <p:sp>
-        <p:nvSpPr>
-          <p:cNvPr id="6" name="hex-2"/>
+          <a:effectLst/>
+        </p:spPr>
+        <p:style>
+          <a:lnRef idx="1">
+            <a:schemeClr val="accent1"/>
+          </a:lnRef>
+          <a:fillRef idx="3">
+            <a:schemeClr val="accent1"/>
+          </a:fillRef>
+          <a:effectRef idx="2">
+            <a:schemeClr val="accent1"/>
+          </a:effectRef>
+          <a:fontRef idx="minor">
+            <a:schemeClr val="lt1"/>
+          </a:fontRef>
+        </p:style>
+        <p:txBody>
+          <a:bodyPr rtlCol="0" anchor="ctr"/>
+          <a:lstStyle/>
+          <a:p>
+            <a:pPr algn="ctr"/>
+          </a:p>
+        </p:txBody>
+      </p:sp>
+      <p:sp>
+        <p:nvSpPr>
+          <p:cNvPr id="6" name="logo-2"/>
           <p:cNvSpPr/>
           <p:nvPr/>
         </p:nvSpPr>
         <p:spPr>
           <a:xfrm>
-            <a:off x="7351776" y="914400"/>
-            <a:ext cx="914400" cy="791870"/>
-          </a:xfrm>
-          <a:prstGeom prst="hexagon">
-            <a:avLst/>
-          </a:prstGeom>
+            <a:off x="7168794" y="1215390"/>
+            <a:ext cx="629361" cy="726440"/>
+          </a:xfrm>
+          <a:custGeom>
+            <a:avLst/>
+            <a:gdLst/>
+            <a:ahLst/>
+            <a:cxnLst/>
+            <a:rect l="l" t="t" r="r" b="b"/>
+            <a:pathLst>
+              <a:path w="629361" h="726440">
+                <a:moveTo>
+                  <a:pt x="314681" y="0"/>
+                </a:moveTo>
+                <a:lnTo>
+                  <a:pt x="629361" y="181610"/>
+                </a:lnTo>
+                <a:lnTo>
+                  <a:pt x="629361" y="544830"/>
+                </a:lnTo>
+                <a:lnTo>
+                  <a:pt x="314681" y="726440"/>
+                </a:lnTo>
+                <a:lnTo>
+                  <a:pt x="0" y="544830"/>
+                </a:lnTo>
+                <a:lnTo>
+                  <a:pt x="0" y="181610"/>
+                </a:lnTo>
+                <a:close/>
+              </a:path>
+            </a:pathLst>
+          </a:custGeom>
           <a:solidFill>
-            <a:srgbClr val="FFFFFF"/>
+            <a:srgbClr val="F4F4F4"/>
           </a:solidFill>
-          <a:ln w="6350">
-            <a:solidFill>
-              <a:srgbClr val="FFFFFF"/>
-            </a:solidFill>
-            <a:prstDash val="solid"/>
+          <a:ln>
+            <a:noFill/>
           </a:ln>
-        </p:spPr>
-      </p:sp>
-      <p:sp>
-        <p:nvSpPr>
-          <p:cNvPr id="7" name="hex-3"/>
+          <a:effectLst/>
+        </p:spPr>
+        <p:style>
+          <a:lnRef idx="1">
+            <a:schemeClr val="accent1"/>
+          </a:lnRef>
+          <a:fillRef idx="3">
+            <a:schemeClr val="accent1"/>
+          </a:fillRef>
+          <a:effectRef idx="2">
+            <a:schemeClr val="accent1"/>
+          </a:effectRef>
+          <a:fontRef idx="minor">
+            <a:schemeClr val="lt1"/>
+          </a:fontRef>
+        </p:style>
+        <p:txBody>
+          <a:bodyPr rtlCol="0" anchor="ctr"/>
+          <a:lstStyle/>
+          <a:p>
+            <a:pPr algn="ctr"/>
+          </a:p>
+        </p:txBody>
+      </p:sp>
+      <p:sp>
+        <p:nvSpPr>
+          <p:cNvPr id="7" name="logo-3"/>
           <p:cNvSpPr/>
           <p:nvPr/>
         </p:nvSpPr>
         <p:spPr>
           <a:xfrm>
-            <a:off x="5852160" y="1779422"/>
-            <a:ext cx="914400" cy="791870"/>
-          </a:xfrm>
-          <a:prstGeom prst="hexagon">
-            <a:avLst/>
-          </a:prstGeom>
+            <a:off x="6425844" y="1215390"/>
+            <a:ext cx="629361" cy="726440"/>
+          </a:xfrm>
+          <a:custGeom>
+            <a:avLst/>
+            <a:gdLst/>
+            <a:ahLst/>
+            <a:cxnLst/>
+            <a:rect l="l" t="t" r="r" b="b"/>
+            <a:pathLst>
+              <a:path w="629361" h="726440">
+                <a:moveTo>
+                  <a:pt x="314681" y="0"/>
+                </a:moveTo>
+                <a:lnTo>
+                  <a:pt x="629361" y="181610"/>
+                </a:lnTo>
+                <a:lnTo>
+                  <a:pt x="629361" y="544830"/>
+                </a:lnTo>
+                <a:lnTo>
+                  <a:pt x="314681" y="726440"/>
+                </a:lnTo>
+                <a:lnTo>
+                  <a:pt x="0" y="544830"/>
+                </a:lnTo>
+                <a:lnTo>
+                  <a:pt x="0" y="181610"/>
+                </a:lnTo>
+                <a:close/>
+              </a:path>
+            </a:pathLst>
+          </a:custGeom>
           <a:solidFill>
-            <a:srgbClr val="FFFFFF"/>
+            <a:srgbClr val="F4F4F4"/>
           </a:solidFill>
-          <a:ln w="6350">
-            <a:solidFill>
-              <a:srgbClr val="FFFFFF"/>
-            </a:solidFill>
-            <a:prstDash val="solid"/>
+          <a:ln>
+            <a:noFill/>
           </a:ln>
-        </p:spPr>
-      </p:sp>
-      <p:sp>
-        <p:nvSpPr>
-          <p:cNvPr id="8" name="hex-4"/>
+          <a:effectLst/>
+        </p:spPr>
+        <p:style>
+          <a:lnRef idx="1">
+            <a:schemeClr val="accent1"/>
+          </a:lnRef>
+          <a:fillRef idx="3">
+            <a:schemeClr val="accent1"/>
+          </a:fillRef>
+          <a:effectRef idx="2">
+            <a:schemeClr val="accent1"/>
+          </a:effectRef>
+          <a:fontRef idx="minor">
+            <a:schemeClr val="lt1"/>
+          </a:fontRef>
+        </p:style>
+        <p:txBody>
+          <a:bodyPr rtlCol="0" anchor="ctr"/>
+          <a:lstStyle/>
+          <a:p>
+            <a:pPr algn="ctr"/>
+          </a:p>
+        </p:txBody>
+      </p:sp>
+      <p:sp>
+        <p:nvSpPr>
+          <p:cNvPr id="8" name="logo-4"/>
           <p:cNvSpPr/>
           <p:nvPr/>
         </p:nvSpPr>
         <p:spPr>
           <a:xfrm>
-            <a:off x="6601968" y="2211934"/>
-            <a:ext cx="914400" cy="791870"/>
-          </a:xfrm>
-          <a:prstGeom prst="hexagon">
-            <a:avLst/>
-          </a:prstGeom>
+            <a:off x="7168794" y="2503170"/>
+            <a:ext cx="629361" cy="726440"/>
+          </a:xfrm>
+          <a:custGeom>
+            <a:avLst/>
+            <a:gdLst/>
+            <a:ahLst/>
+            <a:cxnLst/>
+            <a:rect l="l" t="t" r="r" b="b"/>
+            <a:pathLst>
+              <a:path w="629361" h="726440">
+                <a:moveTo>
+                  <a:pt x="314681" y="0"/>
+                </a:moveTo>
+                <a:lnTo>
+                  <a:pt x="629361" y="181610"/>
+                </a:lnTo>
+                <a:lnTo>
+                  <a:pt x="629361" y="544830"/>
+                </a:lnTo>
+                <a:lnTo>
+                  <a:pt x="314681" y="726440"/>
+                </a:lnTo>
+                <a:lnTo>
+                  <a:pt x="0" y="544830"/>
+                </a:lnTo>
+                <a:lnTo>
+                  <a:pt x="0" y="181610"/>
+                </a:lnTo>
+                <a:close/>
+              </a:path>
+            </a:pathLst>
+          </a:custGeom>
+          <a:solidFill>
+            <a:srgbClr val="F4F4F4"/>
+          </a:solidFill>
+          <a:ln>
+            <a:noFill/>
+          </a:ln>
+          <a:effectLst/>
+        </p:spPr>
+        <p:style>
+          <a:lnRef idx="1">
+            <a:schemeClr val="accent1"/>
+          </a:lnRef>
+          <a:fillRef idx="3">
+            <a:schemeClr val="accent1"/>
+          </a:fillRef>
+          <a:effectRef idx="2">
+            <a:schemeClr val="accent1"/>
+          </a:effectRef>
+          <a:fontRef idx="minor">
+            <a:schemeClr val="lt1"/>
+          </a:fontRef>
+        </p:style>
+        <p:txBody>
+          <a:bodyPr rtlCol="0" anchor="ctr"/>
+          <a:lstStyle/>
+          <a:p>
+            <a:pPr algn="ctr"/>
+          </a:p>
+        </p:txBody>
+      </p:sp>
+      <p:sp>
+        <p:nvSpPr>
+          <p:cNvPr id="9" name="logo-5"/>
+          <p:cNvSpPr/>
+          <p:nvPr/>
+        </p:nvSpPr>
+        <p:spPr>
+          <a:xfrm>
+            <a:off x="6425844" y="2503170"/>
+            <a:ext cx="629361" cy="726440"/>
+          </a:xfrm>
+          <a:custGeom>
+            <a:avLst/>
+            <a:gdLst/>
+            <a:ahLst/>
+            <a:cxnLst/>
+            <a:rect l="l" t="t" r="r" b="b"/>
+            <a:pathLst>
+              <a:path w="629361" h="726440">
+                <a:moveTo>
+                  <a:pt x="314681" y="0"/>
+                </a:moveTo>
+                <a:lnTo>
+                  <a:pt x="629361" y="181610"/>
+                </a:lnTo>
+                <a:lnTo>
+                  <a:pt x="629361" y="544830"/>
+                </a:lnTo>
+                <a:lnTo>
+                  <a:pt x="314681" y="726440"/>
+                </a:lnTo>
+                <a:lnTo>
+                  <a:pt x="0" y="544830"/>
+                </a:lnTo>
+                <a:lnTo>
+                  <a:pt x="0" y="181610"/>
+                </a:lnTo>
+                <a:close/>
+              </a:path>
+            </a:pathLst>
+          </a:custGeom>
+          <a:solidFill>
+            <a:srgbClr val="F4F4F4"/>
+          </a:solidFill>
+          <a:ln>
+            <a:noFill/>
+          </a:ln>
+          <a:effectLst/>
+        </p:spPr>
+        <p:style>
+          <a:lnRef idx="1">
+            <a:schemeClr val="accent1"/>
+          </a:lnRef>
+          <a:fillRef idx="3">
+            <a:schemeClr val="accent1"/>
+          </a:fillRef>
+          <a:effectRef idx="2">
+            <a:schemeClr val="accent1"/>
+          </a:effectRef>
+          <a:fontRef idx="minor">
+            <a:schemeClr val="lt1"/>
+          </a:fontRef>
+        </p:style>
+        <p:txBody>
+          <a:bodyPr rtlCol="0" anchor="ctr"/>
+          <a:lstStyle/>
+          <a:p>
+            <a:pPr algn="ctr"/>
+          </a:p>
+        </p:txBody>
+      </p:sp>
+      <p:sp>
+        <p:nvSpPr>
+          <p:cNvPr id="10" name="logo-center"/>
+          <p:cNvSpPr/>
+          <p:nvPr/>
+        </p:nvSpPr>
+        <p:spPr>
+          <a:xfrm>
+            <a:off x="6797319" y="1859280"/>
+            <a:ext cx="629361" cy="726440"/>
+          </a:xfrm>
+          <a:custGeom>
+            <a:avLst/>
+            <a:gdLst/>
+            <a:ahLst/>
+            <a:cxnLst/>
+            <a:rect l="l" t="t" r="r" b="b"/>
+            <a:pathLst>
+              <a:path w="629361" h="726440">
+                <a:moveTo>
+                  <a:pt x="314681" y="0"/>
+                </a:moveTo>
+                <a:lnTo>
+                  <a:pt x="629361" y="181609"/>
+                </a:lnTo>
+                <a:lnTo>
+                  <a:pt x="629361" y="544830"/>
+                </a:lnTo>
+                <a:lnTo>
+                  <a:pt x="314681" y="726440"/>
+                </a:lnTo>
+                <a:lnTo>
+                  <a:pt x="0" y="544830"/>
+                </a:lnTo>
+                <a:lnTo>
+                  <a:pt x="0" y="181609"/>
+                </a:lnTo>
+                <a:close/>
+              </a:path>
+            </a:pathLst>
+          </a:custGeom>
           <a:solidFill>
             <a:srgbClr val="E2001A"/>
           </a:solidFill>
-          <a:ln w="6350">
-            <a:solidFill>
-              <a:srgbClr val="E2001A"/>
-            </a:solidFill>
-            <a:prstDash val="solid"/>
+          <a:ln>
+            <a:noFill/>
           </a:ln>
-        </p:spPr>
-      </p:sp>
-      <p:sp>
-        <p:nvSpPr>
-          <p:cNvPr id="9" name="hex-5"/>
-          <p:cNvSpPr/>
-          <p:nvPr/>
-        </p:nvSpPr>
-        <p:spPr>
-          <a:xfrm>
-            <a:off x="7351776" y="1779422"/>
-            <a:ext cx="914400" cy="791870"/>
-          </a:xfrm>
-          <a:prstGeom prst="hexagon">
-            <a:avLst/>
-          </a:prstGeom>
-          <a:solidFill>
-            <a:srgbClr val="FFFFFF"/>
-          </a:solidFill>
-          <a:ln w="6350">
-            <a:solidFill>
-              <a:srgbClr val="FFFFFF"/>
-            </a:solidFill>
-            <a:prstDash val="solid"/>
-          </a:ln>
-        </p:spPr>
-      </p:sp>
-      <p:sp>
-        <p:nvSpPr>
-          <p:cNvPr id="10" name="hex-6"/>
-          <p:cNvSpPr/>
-          <p:nvPr/>
-        </p:nvSpPr>
-        <p:spPr>
-          <a:xfrm>
-            <a:off x="6601968" y="3076956"/>
-            <a:ext cx="914400" cy="791870"/>
-          </a:xfrm>
-          <a:prstGeom prst="hexagon">
-            <a:avLst/>
-          </a:prstGeom>
-          <a:solidFill>
-            <a:srgbClr val="FFFFFF"/>
-          </a:solidFill>
-          <a:ln w="6350">
-            <a:solidFill>
-              <a:srgbClr val="FFFFFF"/>
-            </a:solidFill>
-            <a:prstDash val="solid"/>
-          </a:ln>
-        </p:spPr>
-      </p:sp>
-      <p:sp>
-        <p:nvSpPr>
-          <p:cNvPr id="11" name="hex-7"/>
-          <p:cNvSpPr/>
-          <p:nvPr/>
-        </p:nvSpPr>
-        <p:spPr>
-          <a:xfrm>
-            <a:off x="5852160" y="2644445"/>
-            <a:ext cx="914400" cy="791870"/>
-          </a:xfrm>
-          <a:prstGeom prst="hexagon">
-            <a:avLst/>
-          </a:prstGeom>
-          <a:solidFill>
-            <a:srgbClr val="FFFFFF"/>
-          </a:solidFill>
-          <a:ln w="6350">
-            <a:solidFill>
-              <a:srgbClr val="FFFFFF"/>
-            </a:solidFill>
-            <a:prstDash val="solid"/>
-          </a:ln>
-        </p:spPr>
+          <a:effectLst/>
+        </p:spPr>
+        <p:style>
+          <a:lnRef idx="1">
+            <a:schemeClr val="accent1"/>
+          </a:lnRef>
+          <a:fillRef idx="3">
+            <a:schemeClr val="accent1"/>
+          </a:fillRef>
+          <a:effectRef idx="2">
+            <a:schemeClr val="accent1"/>
+          </a:effectRef>
+          <a:fontRef idx="minor">
+            <a:schemeClr val="lt1"/>
+          </a:fontRef>
+        </p:style>
+        <p:txBody>
+          <a:bodyPr rtlCol="0" anchor="ctr"/>
+          <a:lstStyle/>
+          <a:p>
+            <a:pPr algn="ctr"/>
+          </a:p>
+        </p:txBody>
       </p:sp>
     </p:spTree>
   </p:cSld>
@@ -11466,7 +12642,7 @@
         <p:spPr>
           <a:xfrm>
             <a:off x="4937760" y="3017520"/>
-            <a:ext cx="3474720" cy="1371600"/>
+            <a:ext cx="3474720" cy="838200"/>
           </a:xfrm>
           <a:prstGeom prst="rect">
             <a:avLst/>
@@ -11535,6 +12711,91 @@
               <a:t>7</a:t>
             </a:fld>
             <a:endParaRPr lang="en-US"/>
+          </a:p>
+        </p:txBody>
+      </p:sp>
+      <p:sp>
+        <p:nvSpPr>
+          <p:cNvPr id="26" name="fact-bar-0-1"/>
+          <p:cNvSpPr/>
+          <p:nvPr/>
+        </p:nvSpPr>
+        <p:spPr>
+          <a:xfrm>
+            <a:off x="4937760" y="3911600"/>
+            <a:ext cx="38100" cy="482600"/>
+          </a:xfrm>
+          <a:prstGeom prst="rect">
+            <a:avLst/>
+          </a:prstGeom>
+          <a:solidFill>
+            <a:srgbClr val="E2001A"/>
+          </a:solidFill>
+          <a:ln>
+            <a:noFill/>
+          </a:ln>
+          <a:effectLst/>
+        </p:spPr>
+        <p:style>
+          <a:lnRef idx="1">
+            <a:schemeClr val="accent1"/>
+          </a:lnRef>
+          <a:fillRef idx="3">
+            <a:schemeClr val="accent1"/>
+          </a:fillRef>
+          <a:effectRef idx="2">
+            <a:schemeClr val="accent1"/>
+          </a:effectRef>
+          <a:fontRef idx="minor">
+            <a:schemeClr val="lt1"/>
+          </a:fontRef>
+        </p:style>
+        <p:txBody>
+          <a:bodyPr rtlCol="0" anchor="ctr"/>
+          <a:lstStyle/>
+          <a:p>
+            <a:pPr algn="ctr"/>
+          </a:p>
+        </p:txBody>
+      </p:sp>
+      <p:sp>
+        <p:nvSpPr>
+          <p:cNvPr id="27" name="fact-0-1"/>
+          <p:cNvSpPr txBox="1"/>
+          <p:nvPr/>
+        </p:nvSpPr>
+        <p:spPr>
+          <a:xfrm>
+            <a:off x="5064760" y="3911600"/>
+            <a:ext cx="3347720" cy="482600"/>
+          </a:xfrm>
+          <a:prstGeom prst="rect">
+            <a:avLst/>
+          </a:prstGeom>
+          <a:noFill/>
+        </p:spPr>
+        <p:txBody>
+          <a:bodyPr wrap="square" lIns="0" rIns="0" tIns="0" bIns="0">
+            <a:spAutoFit/>
+          </a:bodyPr>
+          <a:lstStyle/>
+          <a:p>
+            <a:r>
+              <a:rPr sz="900" b="1">
+                <a:solidFill>
+                  <a:srgbClr val="E2001A"/>
+                </a:solidFill>
+              </a:rPr>
+              <a:t>MÜNCHEN  </a:t>
+            </a:r>
+            <a:r>
+              <a:rPr sz="1000">
+                <a:solidFill>
+                  <a:srgbClr val="555555"/>
+                </a:solidFill>
+              </a:rPr>
+              <a:t>23,35 € pro m² Angebotsmiete, fast 9 € über dem Bundesschnitt (IfW Kiel, GREIX Q4/2025)</a:t>
+            </a:r>
           </a:p>
         </p:txBody>
       </p:sp>
@@ -11770,7 +13031,7 @@
         <p:spPr>
           <a:xfrm>
             <a:off x="731520" y="3017520"/>
-            <a:ext cx="3474720" cy="1371600"/>
+            <a:ext cx="3474720" cy="838200"/>
           </a:xfrm>
           <a:prstGeom prst="rect">
             <a:avLst/>
@@ -12035,6 +13296,91 @@
               <a:t>8</a:t>
             </a:fld>
             <a:endParaRPr lang="en-US"/>
+          </a:p>
+        </p:txBody>
+      </p:sp>
+      <p:sp>
+        <p:nvSpPr>
+          <p:cNvPr id="26" name="fact-bar-1-0"/>
+          <p:cNvSpPr/>
+          <p:nvPr/>
+        </p:nvSpPr>
+        <p:spPr>
+          <a:xfrm>
+            <a:off x="731520" y="3911600"/>
+            <a:ext cx="38100" cy="482600"/>
+          </a:xfrm>
+          <a:prstGeom prst="rect">
+            <a:avLst/>
+          </a:prstGeom>
+          <a:solidFill>
+            <a:srgbClr val="E2001A"/>
+          </a:solidFill>
+          <a:ln>
+            <a:noFill/>
+          </a:ln>
+          <a:effectLst/>
+        </p:spPr>
+        <p:style>
+          <a:lnRef idx="1">
+            <a:schemeClr val="accent1"/>
+          </a:lnRef>
+          <a:fillRef idx="3">
+            <a:schemeClr val="accent1"/>
+          </a:fillRef>
+          <a:effectRef idx="2">
+            <a:schemeClr val="accent1"/>
+          </a:effectRef>
+          <a:fontRef idx="minor">
+            <a:schemeClr val="lt1"/>
+          </a:fontRef>
+        </p:style>
+        <p:txBody>
+          <a:bodyPr rtlCol="0" anchor="ctr"/>
+          <a:lstStyle/>
+          <a:p>
+            <a:pPr algn="ctr"/>
+          </a:p>
+        </p:txBody>
+      </p:sp>
+      <p:sp>
+        <p:nvSpPr>
+          <p:cNvPr id="27" name="fact-1-0"/>
+          <p:cNvSpPr txBox="1"/>
+          <p:nvPr/>
+        </p:nvSpPr>
+        <p:spPr>
+          <a:xfrm>
+            <a:off x="858520" y="3911600"/>
+            <a:ext cx="3347720" cy="482600"/>
+          </a:xfrm>
+          <a:prstGeom prst="rect">
+            <a:avLst/>
+          </a:prstGeom>
+          <a:noFill/>
+        </p:spPr>
+        <p:txBody>
+          <a:bodyPr wrap="square" lIns="0" rIns="0" tIns="0" bIns="0">
+            <a:spAutoFit/>
+          </a:bodyPr>
+          <a:lstStyle/>
+          <a:p>
+            <a:r>
+              <a:rPr sz="900" b="1">
+                <a:solidFill>
+                  <a:srgbClr val="E2001A"/>
+                </a:solidFill>
+              </a:rPr>
+              <a:t>DEUTSCHLAND  </a:t>
+            </a:r>
+            <a:r>
+              <a:rPr sz="1000">
+                <a:solidFill>
+                  <a:srgbClr val="555555"/>
+                </a:solidFill>
+              </a:rPr>
+              <a:t>Gut jede:r Neunte fühlt sich häufig einsam, über 75-Jährige am stärksten (Einsamkeitsbarometer 2024)</a:t>
+            </a:r>
           </a:p>
         </p:txBody>
       </p:sp>

</xml_diff>